<commit_message>
1. Sitzung: Block zur Literatursuche; Kursbeschreibung aktualisiert
Co-Authored-By: Claude Opus 5.5 <noreply@anthropic.com>
Claude-Session: https://claude.ai/code/session_01VLCMYQ1mounEw5aFg6PJHq
</commit_message>
<xml_diff>
--- a/1._sitzung/Folien_Python_und_Regex.pptx
+++ b/1._sitzung/Folien_Python_und_Regex.pptx
@@ -42,6 +42,9 @@
     <p:sldId id="426" r:id="rId926"/>
     <p:sldId id="427" r:id="rId927"/>
     <p:sldId id="428" r:id="rId928"/>
+    <p:sldId id="429" r:id="rId929"/>
+    <p:sldId id="430" r:id="rId930"/>
+    <p:sldId id="431" r:id="rId931"/>
   </p:sldIdLst>
   <p:sldSz cx="12192000" cy="6858000"/>
   <p:notesSz cx="6858000" cy="9144000"/>
@@ -2558,13 +2561,7 @@
           <a:p>
             <a:r>
               <a:rPr lang="de-DE" dirty="0"/>
-              <a:t>Rest der Sitzung. Kontrolle: i 23′ hat neun Wörter; zwölf verschiedene Logogramme. Am Ende ein Programm am Beamer zeigen.</a:t>
-            </a:r>
-          </a:p>
-          <a:p>
-            <a:r>
-              <a:rPr lang="de-DE" dirty="0"/>
-              <a:t>Vor Schluss: Module verteilen (die ersten zwei am 30.10.).</a:t>
+              <a:t>Die Literatur zu den Modulen liegt zum großen Teil außerhalb der Altorientalistik: Computerlinguistik, Statistik, digitale Klassische Philologie, Bibelwissenschaft. Fast alles auf Englisch.</a:t>
             </a:r>
           </a:p>
         </p:txBody>
@@ -2590,6 +2587,222 @@
 </file>
 
 <file path=ppt/notesSlides/notesSlide128.xml><?xml version="1.0" encoding="utf-8"?>
+<p:notes xmlns:a="http://schemas.openxmlformats.org/drawingml/2006/main" xmlns:r="http://schemas.openxmlformats.org/officeDocument/2006/relationships" xmlns:p="http://schemas.openxmlformats.org/presentationml/2006/main">
+  <p:cSld>
+    <p:spTree>
+      <p:nvGrpSpPr>
+        <p:cNvPr id="1" name=""/>
+        <p:cNvGrpSpPr/>
+        <p:nvPr/>
+      </p:nvGrpSpPr>
+      <p:grpSpPr>
+        <a:xfrm>
+          <a:off x="0" y="0"/>
+          <a:ext cx="0" cy="0"/>
+          <a:chOff x="0" y="0"/>
+          <a:chExt cx="0" cy="0"/>
+        </a:xfrm>
+      </p:grpSpPr>
+      <p:sp>
+        <p:nvSpPr>
+          <p:cNvPr id="2" name="Slide Image Placeholder 1"/>
+          <p:cNvSpPr>
+            <a:spLocks noGrp="1" noRot="1" noChangeAspect="1"/>
+          </p:cNvSpPr>
+          <p:nvPr>
+            <p:ph type="sldImg" idx="2"/>
+          </p:nvPr>
+        </p:nvSpPr>
+        <p:spPr/>
+      </p:sp>
+      <p:sp>
+        <p:nvSpPr>
+          <p:cNvPr id="3" name="Notes Placeholder 2"/>
+          <p:cNvSpPr>
+            <a:spLocks noGrp="1"/>
+          </p:cNvSpPr>
+          <p:nvPr>
+            <p:ph type="body" sz="quarter" idx="3"/>
+          </p:nvPr>
+        </p:nvSpPr>
+        <p:spPr/>
+        <p:txBody>
+          <a:bodyPr/>
+          <a:lstStyle/>
+          <a:p>
+            <a:r>
+              <a:rPr lang="de-DE" dirty="0"/>
+              <a:t>Ausgangspunkte für alle: Leonard 2008 (Kriterien der Philologie) und Coffee et al. 2013 (Tesserae). Von dort rückwärts und vorwärts.</a:t>
+            </a:r>
+          </a:p>
+        </p:txBody>
+      </p:sp>
+      <p:sp>
+        <p:nvSpPr>
+          <p:cNvPr id="4" name="Slide Number Placeholder 3"/>
+          <p:cNvSpPr>
+            <a:spLocks noGrp="1"/>
+          </p:cNvSpPr>
+          <p:nvPr>
+            <p:ph type="sldNum" sz="quarter" idx="5"/>
+          </p:nvPr>
+        </p:nvSpPr>
+        <p:spPr/>
+      </p:sp>
+    </p:spTree>
+  </p:cSld>
+  <p:clrMapOvr>
+    <a:masterClrMapping/>
+  </p:clrMapOvr>
+</p:notes>
+</file>
+
+<file path=ppt/notesSlides/notesSlide129.xml><?xml version="1.0" encoding="utf-8"?>
+<p:notes xmlns:a="http://schemas.openxmlformats.org/drawingml/2006/main" xmlns:r="http://schemas.openxmlformats.org/officeDocument/2006/relationships" xmlns:p="http://schemas.openxmlformats.org/presentationml/2006/main">
+  <p:cSld>
+    <p:spTree>
+      <p:nvGrpSpPr>
+        <p:cNvPr id="1" name=""/>
+        <p:cNvGrpSpPr/>
+        <p:nvPr/>
+      </p:nvGrpSpPr>
+      <p:grpSpPr>
+        <a:xfrm>
+          <a:off x="0" y="0"/>
+          <a:ext cx="0" cy="0"/>
+          <a:chOff x="0" y="0"/>
+          <a:chExt cx="0" cy="0"/>
+        </a:xfrm>
+      </p:grpSpPr>
+      <p:sp>
+        <p:nvSpPr>
+          <p:cNvPr id="2" name="Slide Image Placeholder 1"/>
+          <p:cNvSpPr>
+            <a:spLocks noGrp="1" noRot="1" noChangeAspect="1"/>
+          </p:cNvSpPr>
+          <p:nvPr>
+            <p:ph type="sldImg" idx="2"/>
+          </p:nvPr>
+        </p:nvSpPr>
+        <p:spPr/>
+      </p:sp>
+      <p:sp>
+        <p:nvSpPr>
+          <p:cNvPr id="3" name="Notes Placeholder 2"/>
+          <p:cNvSpPr>
+            <a:spLocks noGrp="1"/>
+          </p:cNvSpPr>
+          <p:nvPr>
+            <p:ph type="body" sz="quarter" idx="3"/>
+          </p:nvPr>
+        </p:nvSpPr>
+        <p:spPr/>
+        <p:txBody>
+          <a:bodyPr/>
+          <a:lstStyle/>
+          <a:p>
+            <a:endParaRPr lang="de-DE"/>
+          </a:p>
+        </p:txBody>
+      </p:sp>
+      <p:sp>
+        <p:nvSpPr>
+          <p:cNvPr id="4" name="Slide Number Placeholder 3"/>
+          <p:cNvSpPr>
+            <a:spLocks noGrp="1"/>
+          </p:cNvSpPr>
+          <p:nvPr>
+            <p:ph type="sldNum" sz="quarter" idx="5"/>
+          </p:nvPr>
+        </p:nvSpPr>
+        <p:spPr/>
+      </p:sp>
+    </p:spTree>
+  </p:cSld>
+  <p:clrMapOvr>
+    <a:masterClrMapping/>
+  </p:clrMapOvr>
+</p:notes>
+</file>
+
+<file path=ppt/notesSlides/notesSlide130.xml><?xml version="1.0" encoding="utf-8"?>
+<p:notes xmlns:a="http://schemas.openxmlformats.org/drawingml/2006/main" xmlns:r="http://schemas.openxmlformats.org/officeDocument/2006/relationships" xmlns:p="http://schemas.openxmlformats.org/presentationml/2006/main">
+  <p:cSld>
+    <p:spTree>
+      <p:nvGrpSpPr>
+        <p:cNvPr id="1" name=""/>
+        <p:cNvGrpSpPr/>
+        <p:nvPr/>
+      </p:nvGrpSpPr>
+      <p:grpSpPr>
+        <a:xfrm>
+          <a:off x="0" y="0"/>
+          <a:ext cx="0" cy="0"/>
+          <a:chOff x="0" y="0"/>
+          <a:chExt cx="0" cy="0"/>
+        </a:xfrm>
+      </p:grpSpPr>
+      <p:sp>
+        <p:nvSpPr>
+          <p:cNvPr id="2" name="Slide Image Placeholder 1"/>
+          <p:cNvSpPr>
+            <a:spLocks noGrp="1" noRot="1" noChangeAspect="1"/>
+          </p:cNvSpPr>
+          <p:nvPr>
+            <p:ph type="sldImg" idx="2"/>
+          </p:nvPr>
+        </p:nvSpPr>
+        <p:spPr/>
+      </p:sp>
+      <p:sp>
+        <p:nvSpPr>
+          <p:cNvPr id="3" name="Notes Placeholder 2"/>
+          <p:cNvSpPr>
+            <a:spLocks noGrp="1"/>
+          </p:cNvSpPr>
+          <p:nvPr>
+            <p:ph type="body" sz="quarter" idx="3"/>
+          </p:nvPr>
+        </p:nvSpPr>
+        <p:spPr/>
+        <p:txBody>
+          <a:bodyPr/>
+          <a:lstStyle/>
+          <a:p>
+            <a:r>
+              <a:rPr lang="de-DE" dirty="0"/>
+              <a:t>Rest der Sitzung. Kontrolle: i 23′ hat neun Wörter; zwölf verschiedene Logogramme. Am Ende ein Programm am Beamer zeigen.</a:t>
+            </a:r>
+          </a:p>
+          <a:p>
+            <a:r>
+              <a:rPr lang="de-DE" dirty="0"/>
+              <a:t>Vor Schluss: Module verteilen (die ersten zwei am 30.10.).</a:t>
+            </a:r>
+          </a:p>
+        </p:txBody>
+      </p:sp>
+      <p:sp>
+        <p:nvSpPr>
+          <p:cNvPr id="4" name="Slide Number Placeholder 3"/>
+          <p:cNvSpPr>
+            <a:spLocks noGrp="1"/>
+          </p:cNvSpPr>
+          <p:nvPr>
+            <p:ph type="sldNum" sz="quarter" idx="5"/>
+          </p:nvPr>
+        </p:nvSpPr>
+        <p:spPr/>
+      </p:sp>
+    </p:spTree>
+  </p:cSld>
+  <p:clrMapOvr>
+    <a:masterClrMapping/>
+  </p:clrMapOvr>
+</p:notes>
+</file>
+
+<file path=ppt/notesSlides/notesSlide131.xml><?xml version="1.0" encoding="utf-8"?>
 <p:notes xmlns:a="http://schemas.openxmlformats.org/drawingml/2006/main" xmlns:r="http://schemas.openxmlformats.org/officeDocument/2006/relationships" xmlns:p="http://schemas.openxmlformats.org/presentationml/2006/main">
   <p:cSld>
     <p:spTree>
@@ -13520,6 +13733,27 @@
                 <a:ea typeface="Cardo"/>
                 <a:cs typeface="Cardo"/>
               </a:rPr>
+              <a:t xml:space="preserve">Literatur finden</a:t>
+            </a:r>
+            <a:endParaRPr lang="de-DE" sz="2000" dirty="0"/>
+          </a:p>
+          <a:p>
+            <a:pPr marL="457200" indent="-457200" algn="l">
+              <a:spcAft>
+                <a:spcPts val="1400"/>
+              </a:spcAft>
+              <a:buFont typeface="+mj-lt"/>
+              <a:buAutoNum type="arabicPeriod"/>
+            </a:pPr>
+            <a:r>
+              <a:rPr lang="de-DE" sz="2000" i="0" dirty="0">
+                <a:solidFill>
+                  <a:srgbClr val="232323"/>
+                </a:solidFill>
+                <a:latin typeface="Cardo"/>
+                <a:ea typeface="Cardo"/>
+                <a:cs typeface="Cardo"/>
+              </a:rPr>
               <a:t xml:space="preserve">Ein erstes Programm</a:t>
             </a:r>
             <a:endParaRPr lang="de-DE" sz="2000" dirty="0"/>
@@ -13534,7 +13768,7 @@
         </p:nvSpPr>
         <p:spPr>
           <a:xfrm>
-            <a:off x="1007999" y="4752000"/>
+            <a:off x="1007999" y="5400000"/>
             <a:ext cx="10188000" cy="360000"/>
           </a:xfrm>
           <a:prstGeom prst="rect">
@@ -24493,7 +24727,476 @@
                 <a:ea typeface="Cardo"/>
                 <a:cs typeface="Cardo"/>
               </a:rPr>
-              <a:t>Übung 6: Ein erstes Programm</a:t>
+              <a:t>Literatur finden: wo?</a:t>
+            </a:r>
+          </a:p>
+        </p:txBody>
+      </p:sp>
+      <p:sp>
+        <p:nvSpPr>
+          <p:cNvPr id="6" name="Spalte 6"/>
+          <p:cNvSpPr txBox="1"/>
+          <p:nvPr/>
+        </p:nvSpPr>
+        <p:spPr>
+          <a:xfrm>
+            <a:off x="1260000" y="1584000"/>
+            <a:ext cx="2520000" cy="360000"/>
+          </a:xfrm>
+          <a:prstGeom prst="rect">
+            <a:avLst/>
+          </a:prstGeom>
+          <a:noFill/>
+        </p:spPr>
+        <p:txBody>
+          <a:bodyPr wrap="square" anchor="t">
+            <a:spAutoFit/>
+          </a:bodyPr>
+          <a:lstStyle/>
+          <a:p>
+            <a:pPr marL="0" indent="0" algn="l">
+              <a:spcAft>
+                <a:spcPts val="1100"/>
+              </a:spcAft>
+              <a:buNone/>
+            </a:pPr>
+            <a:r>
+              <a:rPr lang="de-DE" sz="1900" b="1" i="0" dirty="0">
+                <a:solidFill>
+                  <a:srgbClr val="232323"/>
+                </a:solidFill>
+                <a:latin typeface="Cardo"/>
+                <a:ea typeface="Cardo"/>
+                <a:cs typeface="Cardo"/>
+              </a:rPr>
+              <a:t xml:space="preserve">Google Scholar</a:t>
+            </a:r>
+            <a:endParaRPr lang="de-DE" sz="1900" dirty="0"/>
+          </a:p>
+          <a:p>
+            <a:pPr marL="0" indent="0" algn="l">
+              <a:spcAft>
+                <a:spcPts val="1100"/>
+              </a:spcAft>
+              <a:buNone/>
+            </a:pPr>
+            <a:r>
+              <a:rPr lang="de-DE" sz="1900" b="1" i="0" dirty="0">
+                <a:solidFill>
+                  <a:srgbClr val="232323"/>
+                </a:solidFill>
+                <a:latin typeface="Cardo"/>
+                <a:ea typeface="Cardo"/>
+                <a:cs typeface="Cardo"/>
+              </a:rPr>
+              <a:t xml:space="preserve">Semantic Scholar</a:t>
+            </a:r>
+            <a:endParaRPr lang="de-DE" sz="1900" dirty="0"/>
+          </a:p>
+          <a:p>
+            <a:pPr marL="0" indent="0" algn="l">
+              <a:spcAft>
+                <a:spcPts val="1100"/>
+              </a:spcAft>
+              <a:buNone/>
+            </a:pPr>
+            <a:r>
+              <a:rPr lang="de-DE" sz="1900" b="1" i="0" dirty="0">
+                <a:solidFill>
+                  <a:srgbClr val="232323"/>
+                </a:solidFill>
+                <a:latin typeface="Cardo"/>
+                <a:ea typeface="Cardo"/>
+                <a:cs typeface="Cardo"/>
+              </a:rPr>
+              <a:t xml:space="preserve">ACL Anthology</a:t>
+            </a:r>
+            <a:endParaRPr lang="de-DE" sz="1900" dirty="0"/>
+          </a:p>
+          <a:p>
+            <a:pPr marL="0" indent="0" algn="l">
+              <a:spcAft>
+                <a:spcPts val="1100"/>
+              </a:spcAft>
+              <a:buNone/>
+            </a:pPr>
+            <a:r>
+              <a:rPr lang="de-DE" sz="1900" b="1" i="0" dirty="0">
+                <a:solidFill>
+                  <a:srgbClr val="232323"/>
+                </a:solidFill>
+                <a:latin typeface="Cardo"/>
+                <a:ea typeface="Cardo"/>
+                <a:cs typeface="Cardo"/>
+              </a:rPr>
+              <a:t xml:space="preserve">DBLP</a:t>
+            </a:r>
+            <a:endParaRPr lang="de-DE" sz="1900" dirty="0"/>
+          </a:p>
+          <a:p>
+            <a:pPr marL="0" indent="0" algn="l">
+              <a:spcAft>
+                <a:spcPts val="1100"/>
+              </a:spcAft>
+              <a:buNone/>
+            </a:pPr>
+            <a:r>
+              <a:rPr lang="de-DE" sz="1900" b="1" i="0" dirty="0">
+                <a:solidFill>
+                  <a:srgbClr val="232323"/>
+                </a:solidFill>
+                <a:latin typeface="Cardo"/>
+                <a:ea typeface="Cardo"/>
+                <a:cs typeface="Cardo"/>
+              </a:rPr>
+              <a:t xml:space="preserve">arXiv</a:t>
+            </a:r>
+            <a:endParaRPr lang="de-DE" sz="1900" dirty="0"/>
+          </a:p>
+          <a:p>
+            <a:pPr marL="0" indent="0" algn="l">
+              <a:spcAft>
+                <a:spcPts val="1100"/>
+              </a:spcAft>
+              <a:buNone/>
+            </a:pPr>
+            <a:r>
+              <a:rPr lang="de-DE" sz="1900" b="1" i="0" dirty="0">
+                <a:solidFill>
+                  <a:srgbClr val="232323"/>
+                </a:solidFill>
+                <a:latin typeface="Cardo"/>
+                <a:ea typeface="Cardo"/>
+                <a:cs typeface="Cardo"/>
+              </a:rPr>
+              <a:t xml:space="preserve">KeiBi</a:t>
+            </a:r>
+            <a:endParaRPr lang="de-DE" sz="1900" dirty="0"/>
+          </a:p>
+          <a:p>
+            <a:pPr marL="0" indent="0" algn="l">
+              <a:spcAft>
+                <a:spcPts val="1100"/>
+              </a:spcAft>
+              <a:buNone/>
+            </a:pPr>
+            <a:r>
+              <a:rPr lang="de-DE" sz="1900" b="1" i="0" dirty="0">
+                <a:solidFill>
+                  <a:srgbClr val="232323"/>
+                </a:solidFill>
+                <a:latin typeface="Cardo"/>
+                <a:ea typeface="Cardo"/>
+                <a:cs typeface="Cardo"/>
+              </a:rPr>
+              <a:t xml:space="preserve">UB der LMU</a:t>
+            </a:r>
+            <a:endParaRPr lang="de-DE" sz="1900" dirty="0"/>
+          </a:p>
+        </p:txBody>
+      </p:sp>
+      <p:sp>
+        <p:nvSpPr>
+          <p:cNvPr id="7" name="Spalte 7"/>
+          <p:cNvSpPr txBox="1"/>
+          <p:nvPr/>
+        </p:nvSpPr>
+        <p:spPr>
+          <a:xfrm>
+            <a:off x="3780000" y="1584000"/>
+            <a:ext cx="7200000" cy="360000"/>
+          </a:xfrm>
+          <a:prstGeom prst="rect">
+            <a:avLst/>
+          </a:prstGeom>
+          <a:noFill/>
+        </p:spPr>
+        <p:txBody>
+          <a:bodyPr wrap="square" anchor="t">
+            <a:spAutoFit/>
+          </a:bodyPr>
+          <a:lstStyle/>
+          <a:p>
+            <a:pPr marL="0" indent="0" algn="l">
+              <a:spcAft>
+                <a:spcPts val="1100"/>
+              </a:spcAft>
+              <a:buNone/>
+            </a:pPr>
+            <a:r>
+              <a:rPr lang="de-DE" sz="1900" i="0" dirty="0">
+                <a:solidFill>
+                  <a:srgbClr val="232323"/>
+                </a:solidFill>
+                <a:latin typeface="Cardo"/>
+                <a:ea typeface="Cardo"/>
+                <a:cs typeface="Cardo"/>
+              </a:rPr>
+              <a:t xml:space="preserve">breite Suche; „Zitiert von“; Wendungen in Anführungszeichen</a:t>
+            </a:r>
+            <a:endParaRPr lang="de-DE" sz="1900" dirty="0"/>
+          </a:p>
+          <a:p>
+            <a:pPr marL="0" indent="0" algn="l">
+              <a:spcAft>
+                <a:spcPts val="1100"/>
+              </a:spcAft>
+              <a:buNone/>
+            </a:pPr>
+            <a:r>
+              <a:rPr lang="de-DE" sz="1900" i="0" dirty="0">
+                <a:solidFill>
+                  <a:srgbClr val="232323"/>
+                </a:solidFill>
+                <a:latin typeface="Cardo"/>
+                <a:ea typeface="Cardo"/>
+                <a:cs typeface="Cardo"/>
+              </a:rPr>
+              <a:t xml:space="preserve">Empfehlungen und Kurzfassungen</a:t>
+            </a:r>
+            <a:endParaRPr lang="de-DE" sz="1900" dirty="0"/>
+          </a:p>
+          <a:p>
+            <a:pPr marL="0" indent="0" algn="l">
+              <a:spcAft>
+                <a:spcPts val="1100"/>
+              </a:spcAft>
+              <a:buNone/>
+            </a:pPr>
+            <a:r>
+              <a:rPr lang="de-DE" sz="1900" i="0" dirty="0">
+                <a:solidFill>
+                  <a:srgbClr val="232323"/>
+                </a:solidFill>
+                <a:latin typeface="Cardo"/>
+                <a:ea typeface="Cardo"/>
+                <a:cs typeface="Cardo"/>
+              </a:rPr>
+              <a:t xml:space="preserve">Computerlinguistik, frei zugänglich</a:t>
+            </a:r>
+            <a:endParaRPr lang="de-DE" sz="1900" dirty="0"/>
+          </a:p>
+          <a:p>
+            <a:pPr marL="0" indent="0" algn="l">
+              <a:spcAft>
+                <a:spcPts val="1100"/>
+              </a:spcAft>
+              <a:buNone/>
+            </a:pPr>
+            <a:r>
+              <a:rPr lang="de-DE" sz="1900" i="0" dirty="0">
+                <a:solidFill>
+                  <a:srgbClr val="232323"/>
+                </a:solidFill>
+                <a:latin typeface="Cardo"/>
+                <a:ea typeface="Cardo"/>
+                <a:cs typeface="Cardo"/>
+              </a:rPr>
+              <a:t xml:space="preserve">Informatik; alle Arbeiten einer Person</a:t>
+            </a:r>
+            <a:endParaRPr lang="de-DE" sz="1900" dirty="0"/>
+          </a:p>
+          <a:p>
+            <a:pPr marL="0" indent="0" algn="l">
+              <a:spcAft>
+                <a:spcPts val="1100"/>
+              </a:spcAft>
+              <a:buNone/>
+            </a:pPr>
+            <a:r>
+              <a:rPr lang="de-DE" sz="1900" i="0" dirty="0">
+                <a:solidFill>
+                  <a:srgbClr val="232323"/>
+                </a:solidFill>
+                <a:latin typeface="Cardo"/>
+                <a:ea typeface="Cardo"/>
+                <a:cs typeface="Cardo"/>
+              </a:rPr>
+              <a:t xml:space="preserve">Vorabdrucke, noch nicht begutachtet</a:t>
+            </a:r>
+            <a:endParaRPr lang="de-DE" sz="1900" dirty="0"/>
+          </a:p>
+          <a:p>
+            <a:pPr marL="0" indent="0" algn="l">
+              <a:spcAft>
+                <a:spcPts val="1100"/>
+              </a:spcAft>
+              <a:buNone/>
+            </a:pPr>
+            <a:r>
+              <a:rPr lang="de-DE" sz="1900" i="0" dirty="0">
+                <a:solidFill>
+                  <a:srgbClr val="232323"/>
+                </a:solidFill>
+                <a:latin typeface="Cardo"/>
+                <a:ea typeface="Cardo"/>
+                <a:cs typeface="Cardo"/>
+              </a:rPr>
+              <a:t xml:space="preserve">Keilschriftbibliographie</a:t>
+            </a:r>
+            <a:endParaRPr lang="de-DE" sz="1900" dirty="0"/>
+          </a:p>
+          <a:p>
+            <a:pPr marL="0" indent="0" algn="l">
+              <a:spcAft>
+                <a:spcPts val="1100"/>
+              </a:spcAft>
+              <a:buNone/>
+            </a:pPr>
+            <a:r>
+              <a:rPr lang="de-DE" sz="1900" i="0" dirty="0">
+                <a:solidFill>
+                  <a:srgbClr val="232323"/>
+                </a:solidFill>
+                <a:latin typeface="Cardo"/>
+                <a:ea typeface="Cardo"/>
+                <a:cs typeface="Cardo"/>
+              </a:rPr>
+              <a:t xml:space="preserve">Volltexte über die LMU-Kennung („Zugang über Institution“)</a:t>
+            </a:r>
+            <a:endParaRPr lang="de-DE" sz="1900" dirty="0"/>
+          </a:p>
+        </p:txBody>
+      </p:sp>
+    </p:spTree>
+  </p:cSld>
+  <p:clrMapOvr>
+    <a:masterClrMapping/>
+  </p:clrMapOvr>
+</p:sld>
+</file>
+
+<file path=ppt/slides/slide128.xml><?xml version="1.0" encoding="utf-8"?>
+<p:sld xmlns:a="http://schemas.openxmlformats.org/drawingml/2006/main" xmlns:r="http://schemas.openxmlformats.org/officeDocument/2006/relationships" xmlns:p="http://schemas.openxmlformats.org/presentationml/2006/main">
+  <p:cSld>
+    <p:spTree>
+      <p:nvGrpSpPr>
+        <p:cNvPr id="1" name=""/>
+        <p:cNvGrpSpPr/>
+        <p:nvPr/>
+      </p:nvGrpSpPr>
+      <p:grpSpPr>
+        <a:xfrm>
+          <a:off x="0" y="0"/>
+          <a:ext cx="0" cy="0"/>
+          <a:chOff x="0" y="0"/>
+          <a:chExt cx="0" cy="0"/>
+        </a:xfrm>
+      </p:grpSpPr>
+      <p:sp>
+        <p:nvSpPr>
+          <p:cNvPr id="3" name="Foliennummernplatzhalter 1">
+            <a:extLst>
+              <a:ext uri="{FF2B5EF4-FFF2-40B4-BE49-F238E27FC236}">
+                <a16:creationId xmlns:a16="http://schemas.microsoft.com/office/drawing/2014/main" id="{74C617B9-025D-434A-9329-475080415A47}"/>
+              </a:ext>
+            </a:extLst>
+          </p:cNvPr>
+          <p:cNvSpPr>
+            <a:spLocks noGrp="1"/>
+          </p:cNvSpPr>
+          <p:nvPr>
+            <p:ph type="sldNum" sz="quarter" idx="4"/>
+          </p:nvPr>
+        </p:nvSpPr>
+        <p:spPr/>
+        <p:txBody>
+          <a:bodyPr/>
+          <a:lstStyle/>
+          <a:p>
+            <a:pPr algn="l"/>
+            <a:fld id="{3889EAAA-2A39-E347-B0AA-909793490C00}" type="slidenum">
+              <a:rPr lang="de-DE" smtClean="0"/>
+              <a:pPr algn="l"/>
+              <a:t>2</a:t>
+            </a:fld>
+            <a:endParaRPr lang="de-DE" dirty="0"/>
+          </a:p>
+        </p:txBody>
+      </p:sp>
+      <p:sp>
+        <p:nvSpPr>
+          <p:cNvPr id="4" name="Rectangle 5">
+            <a:extLst>
+              <a:ext uri="{FF2B5EF4-FFF2-40B4-BE49-F238E27FC236}">
+                <a16:creationId xmlns:a16="http://schemas.microsoft.com/office/drawing/2014/main" id="{AC864EB9-2EA0-4164-97DA-8B05DD8A7677}"/>
+              </a:ext>
+            </a:extLst>
+          </p:cNvPr>
+          <p:cNvSpPr/>
+          <p:nvPr/>
+        </p:nvSpPr>
+        <p:spPr>
+          <a:xfrm>
+            <a:off x="119336" y="104775"/>
+            <a:ext cx="11953328" cy="6648450"/>
+          </a:xfrm>
+          <a:prstGeom prst="rect">
+            <a:avLst/>
+          </a:prstGeom>
+          <a:noFill/>
+          <a:ln w="28575">
+            <a:solidFill>
+              <a:schemeClr val="tx2"/>
+            </a:solidFill>
+          </a:ln>
+        </p:spPr>
+        <p:style>
+          <a:lnRef idx="2">
+            <a:schemeClr val="accent1">
+              <a:shade val="50000"/>
+            </a:schemeClr>
+          </a:lnRef>
+          <a:fillRef idx="1">
+            <a:schemeClr val="accent1"/>
+          </a:fillRef>
+          <a:effectRef idx="0">
+            <a:schemeClr val="accent1"/>
+          </a:effectRef>
+          <a:fontRef idx="minor">
+            <a:schemeClr val="lt1"/>
+          </a:fontRef>
+        </p:style>
+        <p:txBody>
+          <a:bodyPr rtlCol="0" anchor="ctr"/>
+          <a:lstStyle/>
+          <a:p>
+            <a:pPr algn="ctr"/>
+            <a:endParaRPr lang="en-US" sz="1350"/>
+          </a:p>
+        </p:txBody>
+      </p:sp>
+      <p:sp>
+        <p:nvSpPr>
+          <p:cNvPr id="5" name="Title 1"/>
+          <p:cNvSpPr>
+            <a:spLocks noGrp="1"/>
+          </p:cNvSpPr>
+          <p:nvPr>
+            <p:ph type="title"/>
+          </p:nvPr>
+        </p:nvSpPr>
+        <p:spPr>
+          <a:xfrm>
+            <a:off x="2300000" y="480000"/>
+            <a:ext cx="7600000" cy="950000"/>
+          </a:xfrm>
+        </p:spPr>
+        <p:txBody>
+          <a:bodyPr anchor="ctr"/>
+          <a:lstStyle/>
+          <a:p>
+            <a:pPr algn="ctr"/>
+            <a:r>
+              <a:rPr sz="2800">
+                <a:solidFill>
+                  <a:srgbClr val="232323"/>
+                </a:solidFill>
+                <a:latin typeface="Cardo"/>
+                <a:ea typeface="Cardo"/>
+                <a:cs typeface="Cardo"/>
+              </a:rPr>
+              <a:t>Literatur finden: wie?</a:t>
             </a:r>
           </a:p>
         </p:txBody>
@@ -24528,6 +25231,17 @@
               <a:buChar char="•"/>
             </a:pPr>
             <a:r>
+              <a:rPr lang="de-DE" sz="2000" b="1" i="0" dirty="0">
+                <a:solidFill>
+                  <a:srgbClr val="232323"/>
+                </a:solidFill>
+                <a:latin typeface="Cardo"/>
+                <a:ea typeface="Cardo"/>
+                <a:cs typeface="Cardo"/>
+              </a:rPr>
+              <a:t xml:space="preserve">Suchbegriffe</a:t>
+            </a:r>
+            <a:r>
               <a:rPr lang="de-DE" sz="2000" i="0" dirty="0">
                 <a:solidFill>
                   <a:srgbClr val="232323"/>
@@ -24536,18 +25250,18 @@
                 <a:ea typeface="Cardo"/>
                 <a:cs typeface="Cardo"/>
               </a:rPr>
-              <a:t xml:space="preserve">Übungsblatt, Teil B: </a:t>
-            </a:r>
-            <a:r>
-              <a:rPr lang="de-DE" sz="1800" i="0" dirty="0">
-                <a:solidFill>
-                  <a:srgbClr val="232323"/>
-                </a:solidFill>
-                <a:latin typeface="Courier New"/>
-                <a:ea typeface="Courier New"/>
-                <a:cs typeface="Courier New"/>
-              </a:rPr>
-              <a:t xml:space="preserve">zeilen.py</a:t>
+              <a:t xml:space="preserve"> auf Englisch: </a:t>
+            </a:r>
+            <a:r>
+              <a:rPr lang="de-DE" sz="2000" i="1" dirty="0">
+                <a:solidFill>
+                  <a:srgbClr val="232323"/>
+                </a:solidFill>
+                <a:latin typeface="Cardo"/>
+                <a:ea typeface="Cardo"/>
+                <a:cs typeface="Cardo"/>
+              </a:rPr>
+              <a:t xml:space="preserve">text reuse detection</a:t>
             </a:r>
             <a:r>
               <a:rPr lang="de-DE" sz="2000" i="0" dirty="0">
@@ -24558,18 +25272,18 @@
                 <a:ea typeface="Cardo"/>
                 <a:cs typeface="Cardo"/>
               </a:rPr>
-              <a:t xml:space="preserve"> für BM.35407 i 13′–23′ (Datei </a:t>
-            </a:r>
-            <a:r>
-              <a:rPr lang="de-DE" sz="1800" i="0" dirty="0">
-                <a:solidFill>
-                  <a:srgbClr val="232323"/>
-                </a:solidFill>
-                <a:latin typeface="Courier New"/>
-                <a:ea typeface="Courier New"/>
-                <a:cs typeface="Courier New"/>
-              </a:rPr>
-              <a:t xml:space="preserve">bm35407.txt</a:t>
+              <a:t xml:space="preserve">, </a:t>
+            </a:r>
+            <a:r>
+              <a:rPr lang="de-DE" sz="2000" i="1" dirty="0">
+                <a:solidFill>
+                  <a:srgbClr val="232323"/>
+                </a:solidFill>
+                <a:latin typeface="Cardo"/>
+                <a:ea typeface="Cardo"/>
+                <a:cs typeface="Cardo"/>
+              </a:rPr>
+              <a:t xml:space="preserve">intertextuality detection</a:t>
             </a:r>
             <a:r>
               <a:rPr lang="de-DE" sz="2000" i="0" dirty="0">
@@ -24580,18 +25294,18 @@
                 <a:ea typeface="Cardo"/>
                 <a:cs typeface="Cardo"/>
               </a:rPr>
-              <a:t xml:space="preserve"> im Ordner </a:t>
-            </a:r>
-            <a:r>
-              <a:rPr lang="de-DE" sz="1800" i="0" dirty="0">
-                <a:solidFill>
-                  <a:srgbClr val="232323"/>
-                </a:solidFill>
-                <a:latin typeface="Courier New"/>
-                <a:ea typeface="Courier New"/>
-                <a:cs typeface="Courier New"/>
-              </a:rPr>
-              <a:t xml:space="preserve">1._sitzung</a:t>
+              <a:t xml:space="preserve">, </a:t>
+            </a:r>
+            <a:r>
+              <a:rPr lang="de-DE" sz="2000" i="1" dirty="0">
+                <a:solidFill>
+                  <a:srgbClr val="232323"/>
+                </a:solidFill>
+                <a:latin typeface="Cardo"/>
+                <a:ea typeface="Cardo"/>
+                <a:cs typeface="Cardo"/>
+              </a:rPr>
+              <a:t xml:space="preserve">allusion</a:t>
             </a:r>
             <a:r>
               <a:rPr lang="de-DE" sz="2000" i="0" dirty="0">
@@ -24602,7 +25316,62 @@
                 <a:ea typeface="Cardo"/>
                 <a:cs typeface="Cardo"/>
               </a:rPr>
-              <a:t xml:space="preserve">)</a:t>
+              <a:t xml:space="preserve">, </a:t>
+            </a:r>
+            <a:r>
+              <a:rPr lang="de-DE" sz="2000" i="1" dirty="0">
+                <a:solidFill>
+                  <a:srgbClr val="232323"/>
+                </a:solidFill>
+                <a:latin typeface="Cardo"/>
+                <a:ea typeface="Cardo"/>
+                <a:cs typeface="Cardo"/>
+              </a:rPr>
+              <a:t xml:space="preserve">lemmatization</a:t>
+            </a:r>
+            <a:r>
+              <a:rPr lang="de-DE" sz="2000" i="0" dirty="0">
+                <a:solidFill>
+                  <a:srgbClr val="232323"/>
+                </a:solidFill>
+                <a:latin typeface="Cardo"/>
+                <a:ea typeface="Cardo"/>
+                <a:cs typeface="Cardo"/>
+              </a:rPr>
+              <a:t xml:space="preserve">, </a:t>
+            </a:r>
+            <a:r>
+              <a:rPr lang="de-DE" sz="2000" i="1" dirty="0">
+                <a:solidFill>
+                  <a:srgbClr val="232323"/>
+                </a:solidFill>
+                <a:latin typeface="Cardo"/>
+                <a:ea typeface="Cardo"/>
+                <a:cs typeface="Cardo"/>
+              </a:rPr>
+              <a:t xml:space="preserve">collocation</a:t>
+            </a:r>
+            <a:r>
+              <a:rPr lang="de-DE" sz="2000" i="0" dirty="0">
+                <a:solidFill>
+                  <a:srgbClr val="232323"/>
+                </a:solidFill>
+                <a:latin typeface="Cardo"/>
+                <a:ea typeface="Cardo"/>
+                <a:cs typeface="Cardo"/>
+              </a:rPr>
+              <a:t xml:space="preserve">, </a:t>
+            </a:r>
+            <a:r>
+              <a:rPr lang="de-DE" sz="2000" i="1" dirty="0">
+                <a:solidFill>
+                  <a:srgbClr val="232323"/>
+                </a:solidFill>
+                <a:latin typeface="Cardo"/>
+                <a:ea typeface="Cardo"/>
+                <a:cs typeface="Cardo"/>
+              </a:rPr>
+              <a:t xml:space="preserve">formulaic language</a:t>
             </a:r>
             <a:endParaRPr lang="de-DE" sz="2000" dirty="0"/>
           </a:p>
@@ -24615,6 +25384,17 @@
               <a:buChar char="•"/>
             </a:pPr>
             <a:r>
+              <a:rPr lang="de-DE" sz="2000" b="1" i="0" dirty="0">
+                <a:solidFill>
+                  <a:srgbClr val="232323"/>
+                </a:solidFill>
+                <a:latin typeface="Cardo"/>
+                <a:ea typeface="Cardo"/>
+                <a:cs typeface="Cardo"/>
+              </a:rPr>
+              <a:t xml:space="preserve">Schneeball:</a:t>
+            </a:r>
+            <a:r>
               <a:rPr lang="de-DE" sz="2000" i="0" dirty="0">
                 <a:solidFill>
                   <a:srgbClr val="232323"/>
@@ -24623,7 +25403,7 @@
                 <a:ea typeface="Cardo"/>
                 <a:cs typeface="Cardo"/>
               </a:rPr>
-              <a:t xml:space="preserve">In Paaren; Tastatur alle 15 Minuten wechseln</a:t>
+              <a:t xml:space="preserve"> von einem guten Aufsatz aus rückwärts (seine Bibliographie) und vorwärts („Zitiert von“)</a:t>
             </a:r>
             <a:endParaRPr lang="de-DE" sz="2000" dirty="0"/>
           </a:p>
@@ -24636,6 +25416,17 @@
               <a:buChar char="•"/>
             </a:pPr>
             <a:r>
+              <a:rPr lang="de-DE" sz="2000" b="1" i="0" dirty="0">
+                <a:solidFill>
+                  <a:srgbClr val="232323"/>
+                </a:solidFill>
+                <a:latin typeface="Cardo"/>
+                <a:ea typeface="Cardo"/>
+                <a:cs typeface="Cardo"/>
+              </a:rPr>
+              <a:t xml:space="preserve">Lesen:</a:t>
+            </a:r>
+            <a:r>
               <a:rPr lang="de-DE" sz="2000" i="0" dirty="0">
                 <a:solidFill>
                   <a:srgbClr val="232323"/>
@@ -24644,7 +25435,71 @@
                 <a:ea typeface="Cardo"/>
                 <a:cs typeface="Cardo"/>
               </a:rPr>
-              <a:t xml:space="preserve">Was heute nicht fertig wird, bis zum 30.10. fertigstellen</a:t>
+              <a:t xml:space="preserve"> zuerst Zusammenfassung, Abbildungen und Schluss; dann entscheiden, ob der ganze Aufsatz nötig ist</a:t>
+            </a:r>
+            <a:endParaRPr lang="de-DE" sz="2000" dirty="0"/>
+          </a:p>
+          <a:p>
+            <a:pPr marL="342900" indent="-342900" algn="l">
+              <a:spcAft>
+                <a:spcPts val="1400"/>
+              </a:spcAft>
+              <a:buFont typeface="Arial"/>
+              <a:buChar char="•"/>
+            </a:pPr>
+            <a:r>
+              <a:rPr lang="de-DE" sz="2000" b="1" i="0" dirty="0">
+                <a:solidFill>
+                  <a:srgbClr val="232323"/>
+                </a:solidFill>
+                <a:latin typeface="Cardo"/>
+                <a:ea typeface="Cardo"/>
+                <a:cs typeface="Cardo"/>
+              </a:rPr>
+              <a:t xml:space="preserve">Sammeln</a:t>
+            </a:r>
+            <a:r>
+              <a:rPr lang="de-DE" sz="2000" i="0" dirty="0">
+                <a:solidFill>
+                  <a:srgbClr val="232323"/>
+                </a:solidFill>
+                <a:latin typeface="Cardo"/>
+                <a:ea typeface="Cardo"/>
+                <a:cs typeface="Cardo"/>
+              </a:rPr>
+              <a:t xml:space="preserve"> mit Zotero (zotero.org); die Browser-Erweiterung übernimmt die Angaben</a:t>
+            </a:r>
+            <a:endParaRPr lang="de-DE" sz="2000" dirty="0"/>
+          </a:p>
+          <a:p>
+            <a:pPr marL="342900" indent="-342900" algn="l">
+              <a:spcAft>
+                <a:spcPts val="1400"/>
+              </a:spcAft>
+              <a:buFont typeface="Arial"/>
+              <a:buChar char="•"/>
+            </a:pPr>
+            <a:r>
+              <a:rPr lang="de-DE" sz="2000" b="1" i="0" dirty="0">
+                <a:solidFill>
+                  <a:srgbClr val="232323"/>
+                </a:solidFill>
+                <a:latin typeface="Cardo"/>
+                <a:ea typeface="Cardo"/>
+                <a:cs typeface="Cardo"/>
+              </a:rPr>
+              <a:t xml:space="preserve">Prüfen:</a:t>
+            </a:r>
+            <a:r>
+              <a:rPr lang="de-DE" sz="2000" i="0" dirty="0">
+                <a:solidFill>
+                  <a:srgbClr val="232323"/>
+                </a:solidFill>
+                <a:latin typeface="Cardo"/>
+                <a:ea typeface="Cardo"/>
+                <a:cs typeface="Cardo"/>
+              </a:rPr>
+              <a:t xml:space="preserve"> Titel, die ein KI-Assistent nennt, immer über die DOI oder im Katalog nachsehen; Sprachmodelle erfinden Literatur</a:t>
             </a:r>
             <a:endParaRPr lang="de-DE" sz="2000" dirty="0"/>
           </a:p>
@@ -24658,7 +25513,628 @@
 </p:sld>
 </file>
 
-<file path=ppt/slides/slide128.xml><?xml version="1.0" encoding="utf-8"?>
+<file path=ppt/slides/slide129.xml><?xml version="1.0" encoding="utf-8"?>
+<p:sld xmlns:a="http://schemas.openxmlformats.org/drawingml/2006/main" xmlns:r="http://schemas.openxmlformats.org/officeDocument/2006/relationships" xmlns:p="http://schemas.openxmlformats.org/presentationml/2006/main">
+  <p:cSld>
+    <p:spTree>
+      <p:nvGrpSpPr>
+        <p:cNvPr id="1" name=""/>
+        <p:cNvGrpSpPr/>
+        <p:nvPr/>
+      </p:nvGrpSpPr>
+      <p:grpSpPr>
+        <a:xfrm>
+          <a:off x="0" y="0"/>
+          <a:ext cx="0" cy="0"/>
+          <a:chOff x="0" y="0"/>
+          <a:chExt cx="0" cy="0"/>
+        </a:xfrm>
+      </p:grpSpPr>
+      <p:sp>
+        <p:nvSpPr>
+          <p:cNvPr id="3" name="Foliennummernplatzhalter 1">
+            <a:extLst>
+              <a:ext uri="{FF2B5EF4-FFF2-40B4-BE49-F238E27FC236}">
+                <a16:creationId xmlns:a16="http://schemas.microsoft.com/office/drawing/2014/main" id="{74C617B9-025D-434A-9329-475080415A47}"/>
+              </a:ext>
+            </a:extLst>
+          </p:cNvPr>
+          <p:cNvSpPr>
+            <a:spLocks noGrp="1"/>
+          </p:cNvSpPr>
+          <p:nvPr>
+            <p:ph type="sldNum" sz="quarter" idx="4"/>
+          </p:nvPr>
+        </p:nvSpPr>
+        <p:spPr/>
+        <p:txBody>
+          <a:bodyPr/>
+          <a:lstStyle/>
+          <a:p>
+            <a:pPr algn="l"/>
+            <a:fld id="{3889EAAA-2A39-E347-B0AA-909793490C00}" type="slidenum">
+              <a:rPr lang="de-DE" smtClean="0"/>
+              <a:pPr algn="l"/>
+              <a:t>2</a:t>
+            </a:fld>
+            <a:endParaRPr lang="de-DE" dirty="0"/>
+          </a:p>
+        </p:txBody>
+      </p:sp>
+      <p:sp>
+        <p:nvSpPr>
+          <p:cNvPr id="4" name="Rectangle 5">
+            <a:extLst>
+              <a:ext uri="{FF2B5EF4-FFF2-40B4-BE49-F238E27FC236}">
+                <a16:creationId xmlns:a16="http://schemas.microsoft.com/office/drawing/2014/main" id="{AC864EB9-2EA0-4164-97DA-8B05DD8A7677}"/>
+              </a:ext>
+            </a:extLst>
+          </p:cNvPr>
+          <p:cNvSpPr/>
+          <p:nvPr/>
+        </p:nvSpPr>
+        <p:spPr>
+          <a:xfrm>
+            <a:off x="119336" y="104775"/>
+            <a:ext cx="11953328" cy="6648450"/>
+          </a:xfrm>
+          <a:prstGeom prst="rect">
+            <a:avLst/>
+          </a:prstGeom>
+          <a:noFill/>
+          <a:ln w="28575">
+            <a:solidFill>
+              <a:schemeClr val="tx2"/>
+            </a:solidFill>
+          </a:ln>
+        </p:spPr>
+        <p:style>
+          <a:lnRef idx="2">
+            <a:schemeClr val="accent1">
+              <a:shade val="50000"/>
+            </a:schemeClr>
+          </a:lnRef>
+          <a:fillRef idx="1">
+            <a:schemeClr val="accent1"/>
+          </a:fillRef>
+          <a:effectRef idx="0">
+            <a:schemeClr val="accent1"/>
+          </a:effectRef>
+          <a:fontRef idx="minor">
+            <a:schemeClr val="lt1"/>
+          </a:fontRef>
+        </p:style>
+        <p:txBody>
+          <a:bodyPr rtlCol="0" anchor="ctr"/>
+          <a:lstStyle/>
+          <a:p>
+            <a:pPr algn="ctr"/>
+            <a:endParaRPr lang="en-US" sz="1350"/>
+          </a:p>
+        </p:txBody>
+      </p:sp>
+      <p:sp>
+        <p:nvSpPr>
+          <p:cNvPr id="5" name="Title 1"/>
+          <p:cNvSpPr>
+            <a:spLocks noGrp="1"/>
+          </p:cNvSpPr>
+          <p:nvPr>
+            <p:ph type="title"/>
+          </p:nvPr>
+        </p:nvSpPr>
+        <p:spPr>
+          <a:xfrm>
+            <a:off x="2300000" y="480000"/>
+            <a:ext cx="7600000" cy="950000"/>
+          </a:xfrm>
+        </p:spPr>
+        <p:txBody>
+          <a:bodyPr anchor="ctr"/>
+          <a:lstStyle/>
+          <a:p>
+            <a:pPr algn="ctr"/>
+            <a:r>
+              <a:rPr sz="2800">
+                <a:solidFill>
+                  <a:srgbClr val="232323"/>
+                </a:solidFill>
+                <a:latin typeface="Cardo"/>
+                <a:ea typeface="Cardo"/>
+                <a:cs typeface="Cardo"/>
+              </a:rPr>
+              <a:t>Übung 6: Literatur finden</a:t>
+            </a:r>
+          </a:p>
+        </p:txBody>
+      </p:sp>
+      <p:sp>
+        <p:nvSpPr>
+          <p:cNvPr id="6" name="TextBox 6"/>
+          <p:cNvSpPr txBox="1"/>
+          <p:nvPr/>
+        </p:nvSpPr>
+        <p:spPr>
+          <a:xfrm>
+            <a:off x="1007999" y="1764000"/>
+            <a:ext cx="10188000" cy="360000"/>
+          </a:xfrm>
+          <a:prstGeom prst="rect">
+            <a:avLst/>
+          </a:prstGeom>
+          <a:noFill/>
+        </p:spPr>
+        <p:txBody>
+          <a:bodyPr wrap="square" anchor="t">
+            <a:spAutoFit/>
+          </a:bodyPr>
+          <a:lstStyle/>
+          <a:p>
+            <a:pPr marL="457200" indent="-457200" algn="l">
+              <a:spcAft>
+                <a:spcPts val="1400"/>
+              </a:spcAft>
+              <a:buFont typeface="+mj-lt"/>
+              <a:buAutoNum type="arabicPeriod"/>
+            </a:pPr>
+            <a:r>
+              <a:rPr lang="de-DE" sz="2000" i="0" dirty="0">
+                <a:solidFill>
+                  <a:srgbClr val="232323"/>
+                </a:solidFill>
+                <a:latin typeface="Cardo"/>
+                <a:ea typeface="Cardo"/>
+                <a:cs typeface="Cardo"/>
+              </a:rPr>
+              <a:t xml:space="preserve">Google Scholar: „The Tesserae Project: Intertextual Analysis of Latin Poetry“. Wie oft wird der Aufsatz zitiert?</a:t>
+            </a:r>
+            <a:endParaRPr lang="de-DE" sz="2000" dirty="0"/>
+          </a:p>
+          <a:p>
+            <a:pPr marL="457200" indent="-457200" algn="l">
+              <a:spcAft>
+                <a:spcPts val="1400"/>
+              </a:spcAft>
+              <a:buFont typeface="+mj-lt"/>
+              <a:buAutoNum type="arabicPeriod"/>
+            </a:pPr>
+            <a:r>
+              <a:rPr lang="de-DE" sz="2000" i="0" dirty="0">
+                <a:solidFill>
+                  <a:srgbClr val="232323"/>
+                </a:solidFill>
+                <a:latin typeface="Cardo"/>
+                <a:ea typeface="Cardo"/>
+                <a:cs typeface="Cardo"/>
+              </a:rPr>
+              <a:t xml:space="preserve">Unter „Zitiert von“ einen Aufsatz finden, der das Verfahren auf eine andere Sprache überträgt</a:t>
+            </a:r>
+            <a:endParaRPr lang="de-DE" sz="2000" dirty="0"/>
+          </a:p>
+          <a:p>
+            <a:pPr marL="457200" indent="-457200" algn="l">
+              <a:spcAft>
+                <a:spcPts val="1400"/>
+              </a:spcAft>
+              <a:buFont typeface="+mj-lt"/>
+              <a:buAutoNum type="arabicPeriod"/>
+            </a:pPr>
+            <a:r>
+              <a:rPr lang="de-DE" sz="2000" i="0" dirty="0">
+                <a:solidFill>
+                  <a:srgbClr val="232323"/>
+                </a:solidFill>
+                <a:latin typeface="Cardo"/>
+                <a:ea typeface="Cardo"/>
+                <a:cs typeface="Cardo"/>
+              </a:rPr>
+              <a:t xml:space="preserve">ACL Anthology: nach </a:t>
+            </a:r>
+            <a:r>
+              <a:rPr lang="de-DE" sz="2000" i="1" dirty="0">
+                <a:solidFill>
+                  <a:srgbClr val="232323"/>
+                </a:solidFill>
+                <a:latin typeface="Cardo"/>
+                <a:ea typeface="Cardo"/>
+                <a:cs typeface="Cardo"/>
+              </a:rPr>
+              <a:t xml:space="preserve">text reuse</a:t>
+            </a:r>
+            <a:r>
+              <a:rPr lang="de-DE" sz="2000" i="0" dirty="0">
+                <a:solidFill>
+                  <a:srgbClr val="232323"/>
+                </a:solidFill>
+                <a:latin typeface="Cardo"/>
+                <a:ea typeface="Cardo"/>
+                <a:cs typeface="Cardo"/>
+              </a:rPr>
+              <a:t xml:space="preserve"> suchen und einen Aufsatz von 2020 oder später auswählen</a:t>
+            </a:r>
+            <a:endParaRPr lang="de-DE" sz="2000" dirty="0"/>
+          </a:p>
+          <a:p>
+            <a:pPr marL="457200" indent="-457200" algn="l">
+              <a:spcAft>
+                <a:spcPts val="1400"/>
+              </a:spcAft>
+              <a:buFont typeface="+mj-lt"/>
+              <a:buAutoNum type="arabicPeriod"/>
+            </a:pPr>
+            <a:r>
+              <a:rPr lang="de-DE" sz="2000" i="0" dirty="0">
+                <a:solidFill>
+                  <a:srgbClr val="232323"/>
+                </a:solidFill>
+                <a:latin typeface="Cardo"/>
+                <a:ea typeface="Cardo"/>
+                <a:cs typeface="Cardo"/>
+              </a:rPr>
+              <a:t xml:space="preserve">KeiBi: nach Wisnom, </a:t>
+            </a:r>
+            <a:r>
+              <a:rPr lang="de-DE" sz="2000" i="1" dirty="0">
+                <a:solidFill>
+                  <a:srgbClr val="232323"/>
+                </a:solidFill>
+                <a:latin typeface="Cardo"/>
+                <a:ea typeface="Cardo"/>
+                <a:cs typeface="Cardo"/>
+              </a:rPr>
+              <a:t xml:space="preserve">Weapons of Words</a:t>
+            </a:r>
+            <a:r>
+              <a:rPr lang="de-DE" sz="2000" i="0" dirty="0">
+                <a:solidFill>
+                  <a:srgbClr val="232323"/>
+                </a:solidFill>
+                <a:latin typeface="Cardo"/>
+                <a:ea typeface="Cardo"/>
+                <a:cs typeface="Cardo"/>
+              </a:rPr>
+              <a:t xml:space="preserve"> suchen. Gibt es Rezensionen?</a:t>
+            </a:r>
+            <a:endParaRPr lang="de-DE" sz="2000" dirty="0"/>
+          </a:p>
+          <a:p>
+            <a:pPr marL="457200" indent="-457200" algn="l">
+              <a:spcAft>
+                <a:spcPts val="1400"/>
+              </a:spcAft>
+              <a:buFont typeface="+mj-lt"/>
+              <a:buAutoNum type="arabicPeriod"/>
+            </a:pPr>
+            <a:r>
+              <a:rPr lang="de-DE" sz="2000" b="1" i="0" dirty="0">
+                <a:solidFill>
+                  <a:srgbClr val="232323"/>
+                </a:solidFill>
+                <a:latin typeface="Cardo"/>
+                <a:ea typeface="Cardo"/>
+                <a:cs typeface="Cardo"/>
+              </a:rPr>
+              <a:t xml:space="preserve">Zusatz:</a:t>
+            </a:r>
+            <a:r>
+              <a:rPr lang="de-DE" sz="2000" i="0" dirty="0">
+                <a:solidFill>
+                  <a:srgbClr val="232323"/>
+                </a:solidFill>
+                <a:latin typeface="Cardo"/>
+                <a:ea typeface="Cardo"/>
+                <a:cs typeface="Cardo"/>
+              </a:rPr>
+              <a:t xml:space="preserve"> Zotero installieren und die gefundenen Titel speichern</a:t>
+            </a:r>
+            <a:endParaRPr lang="de-DE" sz="2000" dirty="0"/>
+          </a:p>
+        </p:txBody>
+      </p:sp>
+    </p:spTree>
+  </p:cSld>
+  <p:clrMapOvr>
+    <a:masterClrMapping/>
+  </p:clrMapOvr>
+</p:sld>
+</file>
+
+<file path=ppt/slides/slide130.xml><?xml version="1.0" encoding="utf-8"?>
+<p:sld xmlns:a="http://schemas.openxmlformats.org/drawingml/2006/main" xmlns:r="http://schemas.openxmlformats.org/officeDocument/2006/relationships" xmlns:p="http://schemas.openxmlformats.org/presentationml/2006/main">
+  <p:cSld>
+    <p:spTree>
+      <p:nvGrpSpPr>
+        <p:cNvPr id="1" name=""/>
+        <p:cNvGrpSpPr/>
+        <p:nvPr/>
+      </p:nvGrpSpPr>
+      <p:grpSpPr>
+        <a:xfrm>
+          <a:off x="0" y="0"/>
+          <a:ext cx="0" cy="0"/>
+          <a:chOff x="0" y="0"/>
+          <a:chExt cx="0" cy="0"/>
+        </a:xfrm>
+      </p:grpSpPr>
+      <p:sp>
+        <p:nvSpPr>
+          <p:cNvPr id="3" name="Foliennummernplatzhalter 1">
+            <a:extLst>
+              <a:ext uri="{FF2B5EF4-FFF2-40B4-BE49-F238E27FC236}">
+                <a16:creationId xmlns:a16="http://schemas.microsoft.com/office/drawing/2014/main" id="{74C617B9-025D-434A-9329-475080415A47}"/>
+              </a:ext>
+            </a:extLst>
+          </p:cNvPr>
+          <p:cNvSpPr>
+            <a:spLocks noGrp="1"/>
+          </p:cNvSpPr>
+          <p:nvPr>
+            <p:ph type="sldNum" sz="quarter" idx="4"/>
+          </p:nvPr>
+        </p:nvSpPr>
+        <p:spPr/>
+        <p:txBody>
+          <a:bodyPr/>
+          <a:lstStyle/>
+          <a:p>
+            <a:pPr algn="l"/>
+            <a:fld id="{3889EAAA-2A39-E347-B0AA-909793490C00}" type="slidenum">
+              <a:rPr lang="de-DE" smtClean="0"/>
+              <a:pPr algn="l"/>
+              <a:t>2</a:t>
+            </a:fld>
+            <a:endParaRPr lang="de-DE" dirty="0"/>
+          </a:p>
+        </p:txBody>
+      </p:sp>
+      <p:sp>
+        <p:nvSpPr>
+          <p:cNvPr id="4" name="Rectangle 5">
+            <a:extLst>
+              <a:ext uri="{FF2B5EF4-FFF2-40B4-BE49-F238E27FC236}">
+                <a16:creationId xmlns:a16="http://schemas.microsoft.com/office/drawing/2014/main" id="{AC864EB9-2EA0-4164-97DA-8B05DD8A7677}"/>
+              </a:ext>
+            </a:extLst>
+          </p:cNvPr>
+          <p:cNvSpPr/>
+          <p:nvPr/>
+        </p:nvSpPr>
+        <p:spPr>
+          <a:xfrm>
+            <a:off x="119336" y="104775"/>
+            <a:ext cx="11953328" cy="6648450"/>
+          </a:xfrm>
+          <a:prstGeom prst="rect">
+            <a:avLst/>
+          </a:prstGeom>
+          <a:noFill/>
+          <a:ln w="28575">
+            <a:solidFill>
+              <a:schemeClr val="tx2"/>
+            </a:solidFill>
+          </a:ln>
+        </p:spPr>
+        <p:style>
+          <a:lnRef idx="2">
+            <a:schemeClr val="accent1">
+              <a:shade val="50000"/>
+            </a:schemeClr>
+          </a:lnRef>
+          <a:fillRef idx="1">
+            <a:schemeClr val="accent1"/>
+          </a:fillRef>
+          <a:effectRef idx="0">
+            <a:schemeClr val="accent1"/>
+          </a:effectRef>
+          <a:fontRef idx="minor">
+            <a:schemeClr val="lt1"/>
+          </a:fontRef>
+        </p:style>
+        <p:txBody>
+          <a:bodyPr rtlCol="0" anchor="ctr"/>
+          <a:lstStyle/>
+          <a:p>
+            <a:pPr algn="ctr"/>
+            <a:endParaRPr lang="en-US" sz="1350"/>
+          </a:p>
+        </p:txBody>
+      </p:sp>
+      <p:sp>
+        <p:nvSpPr>
+          <p:cNvPr id="5" name="Title 1"/>
+          <p:cNvSpPr>
+            <a:spLocks noGrp="1"/>
+          </p:cNvSpPr>
+          <p:nvPr>
+            <p:ph type="title"/>
+          </p:nvPr>
+        </p:nvSpPr>
+        <p:spPr>
+          <a:xfrm>
+            <a:off x="2300000" y="480000"/>
+            <a:ext cx="7600000" cy="950000"/>
+          </a:xfrm>
+        </p:spPr>
+        <p:txBody>
+          <a:bodyPr anchor="ctr"/>
+          <a:lstStyle/>
+          <a:p>
+            <a:pPr algn="ctr"/>
+            <a:r>
+              <a:rPr sz="2800">
+                <a:solidFill>
+                  <a:srgbClr val="232323"/>
+                </a:solidFill>
+                <a:latin typeface="Cardo"/>
+                <a:ea typeface="Cardo"/>
+                <a:cs typeface="Cardo"/>
+              </a:rPr>
+              <a:t>Übung 7: Ein erstes Programm</a:t>
+            </a:r>
+          </a:p>
+        </p:txBody>
+      </p:sp>
+      <p:sp>
+        <p:nvSpPr>
+          <p:cNvPr id="6" name="TextBox 6"/>
+          <p:cNvSpPr txBox="1"/>
+          <p:nvPr/>
+        </p:nvSpPr>
+        <p:spPr>
+          <a:xfrm>
+            <a:off x="1007999" y="1764000"/>
+            <a:ext cx="10188000" cy="360000"/>
+          </a:xfrm>
+          <a:prstGeom prst="rect">
+            <a:avLst/>
+          </a:prstGeom>
+          <a:noFill/>
+        </p:spPr>
+        <p:txBody>
+          <a:bodyPr wrap="square" anchor="t">
+            <a:spAutoFit/>
+          </a:bodyPr>
+          <a:lstStyle/>
+          <a:p>
+            <a:pPr marL="342900" indent="-342900" algn="l">
+              <a:spcAft>
+                <a:spcPts val="1400"/>
+              </a:spcAft>
+              <a:buFont typeface="Arial"/>
+              <a:buChar char="•"/>
+            </a:pPr>
+            <a:r>
+              <a:rPr lang="de-DE" sz="2000" i="0" dirty="0">
+                <a:solidFill>
+                  <a:srgbClr val="232323"/>
+                </a:solidFill>
+                <a:latin typeface="Cardo"/>
+                <a:ea typeface="Cardo"/>
+                <a:cs typeface="Cardo"/>
+              </a:rPr>
+              <a:t xml:space="preserve">Übungsblatt, Teil B: </a:t>
+            </a:r>
+            <a:r>
+              <a:rPr lang="de-DE" sz="1800" i="0" dirty="0">
+                <a:solidFill>
+                  <a:srgbClr val="232323"/>
+                </a:solidFill>
+                <a:latin typeface="Courier New"/>
+                <a:ea typeface="Courier New"/>
+                <a:cs typeface="Courier New"/>
+              </a:rPr>
+              <a:t xml:space="preserve">zeilen.py</a:t>
+            </a:r>
+            <a:r>
+              <a:rPr lang="de-DE" sz="2000" i="0" dirty="0">
+                <a:solidFill>
+                  <a:srgbClr val="232323"/>
+                </a:solidFill>
+                <a:latin typeface="Cardo"/>
+                <a:ea typeface="Cardo"/>
+                <a:cs typeface="Cardo"/>
+              </a:rPr>
+              <a:t xml:space="preserve"> für BM.35407 i 13′–23′ (Datei </a:t>
+            </a:r>
+            <a:r>
+              <a:rPr lang="de-DE" sz="1800" i="0" dirty="0">
+                <a:solidFill>
+                  <a:srgbClr val="232323"/>
+                </a:solidFill>
+                <a:latin typeface="Courier New"/>
+                <a:ea typeface="Courier New"/>
+                <a:cs typeface="Courier New"/>
+              </a:rPr>
+              <a:t xml:space="preserve">bm35407.txt</a:t>
+            </a:r>
+            <a:r>
+              <a:rPr lang="de-DE" sz="2000" i="0" dirty="0">
+                <a:solidFill>
+                  <a:srgbClr val="232323"/>
+                </a:solidFill>
+                <a:latin typeface="Cardo"/>
+                <a:ea typeface="Cardo"/>
+                <a:cs typeface="Cardo"/>
+              </a:rPr>
+              <a:t xml:space="preserve"> im Ordner </a:t>
+            </a:r>
+            <a:r>
+              <a:rPr lang="de-DE" sz="1800" i="0" dirty="0">
+                <a:solidFill>
+                  <a:srgbClr val="232323"/>
+                </a:solidFill>
+                <a:latin typeface="Courier New"/>
+                <a:ea typeface="Courier New"/>
+                <a:cs typeface="Courier New"/>
+              </a:rPr>
+              <a:t xml:space="preserve">1._sitzung</a:t>
+            </a:r>
+            <a:r>
+              <a:rPr lang="de-DE" sz="2000" i="0" dirty="0">
+                <a:solidFill>
+                  <a:srgbClr val="232323"/>
+                </a:solidFill>
+                <a:latin typeface="Cardo"/>
+                <a:ea typeface="Cardo"/>
+                <a:cs typeface="Cardo"/>
+              </a:rPr>
+              <a:t xml:space="preserve">)</a:t>
+            </a:r>
+            <a:endParaRPr lang="de-DE" sz="2000" dirty="0"/>
+          </a:p>
+          <a:p>
+            <a:pPr marL="342900" indent="-342900" algn="l">
+              <a:spcAft>
+                <a:spcPts val="1400"/>
+              </a:spcAft>
+              <a:buFont typeface="Arial"/>
+              <a:buChar char="•"/>
+            </a:pPr>
+            <a:r>
+              <a:rPr lang="de-DE" sz="2000" i="0" dirty="0">
+                <a:solidFill>
+                  <a:srgbClr val="232323"/>
+                </a:solidFill>
+                <a:latin typeface="Cardo"/>
+                <a:ea typeface="Cardo"/>
+                <a:cs typeface="Cardo"/>
+              </a:rPr>
+              <a:t xml:space="preserve">In Paaren; Tastatur alle 15 Minuten wechseln</a:t>
+            </a:r>
+            <a:endParaRPr lang="de-DE" sz="2000" dirty="0"/>
+          </a:p>
+          <a:p>
+            <a:pPr marL="342900" indent="-342900" algn="l">
+              <a:spcAft>
+                <a:spcPts val="1400"/>
+              </a:spcAft>
+              <a:buFont typeface="Arial"/>
+              <a:buChar char="•"/>
+            </a:pPr>
+            <a:r>
+              <a:rPr lang="de-DE" sz="2000" i="0" dirty="0">
+                <a:solidFill>
+                  <a:srgbClr val="232323"/>
+                </a:solidFill>
+                <a:latin typeface="Cardo"/>
+                <a:ea typeface="Cardo"/>
+                <a:cs typeface="Cardo"/>
+              </a:rPr>
+              <a:t xml:space="preserve">Was heute nicht fertig wird, bis zum 30.10. fertigstellen</a:t>
+            </a:r>
+            <a:endParaRPr lang="de-DE" sz="2000" dirty="0"/>
+          </a:p>
+        </p:txBody>
+      </p:sp>
+    </p:spTree>
+  </p:cSld>
+  <p:clrMapOvr>
+    <a:masterClrMapping/>
+  </p:clrMapOvr>
+</p:sld>
+</file>
+
+<file path=ppt/slides/slide131.xml><?xml version="1.0" encoding="utf-8"?>
 <p:sld xmlns:a="http://schemas.openxmlformats.org/drawingml/2006/main" xmlns:r="http://schemas.openxmlformats.org/officeDocument/2006/relationships" xmlns:p="http://schemas.openxmlformats.org/presentationml/2006/main">
   <p:cSld>
     <p:spTree>

</xml_diff>